<commit_message>
fix(auth): add cloud domain auto-detection in Firebase OAuth modal, fallback defaults, and cache buster
</commit_message>
<xml_diff>
--- a/NexusEdu_AI_Mini_Project_Presentation.pptx
+++ b/NexusEdu_AI_Mini_Project_Presentation.pptx
@@ -3769,7 +3769,7 @@
               </a:defRPr>
             </a:pPr>
             <a:r>
-              <a:t>MODULE 03: AI Diagnostic Engine &amp; Arena</a:t>
+              <a:t>MODULE 03: AI Automated Assessment &amp; Arena</a:t>
             </a:r>
           </a:p>
           <a:p>
@@ -3782,7 +3782,7 @@
               </a:defRPr>
             </a:pPr>
             <a:r>
-              <a:t>• Placement readiness score (0-100%) across DSA, Git &amp; OS.</a:t>
+              <a:t>• Submissions evaluated under teacher assignments &amp; auto-marked Complete.</a:t>
             </a:r>
           </a:p>
           <a:p>
@@ -3795,7 +3795,7 @@
               </a:defRPr>
             </a:pPr>
             <a:r>
-              <a:t>• AI Code Arena: Roast, Turbo Optimize &amp; Edge Cases.</a:t>
+              <a:t>• Interactive AI Code Arena: Real-time Roast, Big-O Turbo Optimizer &amp; Edge Cases.</a:t>
             </a:r>
           </a:p>
           <a:p>
@@ -3808,7 +3808,7 @@
               </a:defRPr>
             </a:pPr>
             <a:r>
-              <a:t>• FAANG Mock Interview Challenge Simulator.</a:t>
+              <a:t>• FAANG Mock Interview Simulator with dynamic difficulty &amp; algorithmic feedback.</a:t>
             </a:r>
           </a:p>
         </p:txBody>
@@ -3957,7 +3957,7 @@
               </a:defRPr>
             </a:pPr>
             <a:r>
-              <a:t>MODULE 05: Faculty Management Portal</a:t>
+              <a:t>MODULE 05: Faculty Coursework &amp; Resource Hub</a:t>
             </a:r>
           </a:p>
           <a:p>
@@ -3970,7 +3970,7 @@
               </a:defRPr>
             </a:pPr>
             <a:r>
-              <a:t>• Coursework publishing with section targeting.</a:t>
+              <a:t>• Multi-Format Uploads: Faculty can upload any coursework file (PDF, ZIP, code, sheets).</a:t>
             </a:r>
           </a:p>
           <a:p>
@@ -3983,7 +3983,7 @@
               </a:defRPr>
             </a:pPr>
             <a:r>
-              <a:t>• AI-assisted assignment drafting with starter code.</a:t>
+              <a:t>• Assignment Publishing: Create targeted assignments with starter files &amp; rubric rules.</a:t>
             </a:r>
           </a:p>
           <a:p>
@@ -3996,7 +3996,7 @@
               </a:defRPr>
             </a:pPr>
             <a:r>
-              <a:t>• Student submission review queue with rubric grading.</a:t>
+              <a:t>• Submission Linkage: Direct mapping of student submissions to parent teacher assignments.</a:t>
             </a:r>
           </a:p>
         </p:txBody>
@@ -4374,7 +4374,7 @@
               </a:defRPr>
             </a:pPr>
             <a:r>
-              <a:t>• Local Server Status:</a:t>
+              <a:t>• Faculty Coursework Drive:</a:t>
             </a:r>
           </a:p>
           <a:p>
@@ -4387,7 +4387,7 @@
               </a:defRPr>
             </a:pPr>
             <a:r>
-              <a:t>ACTIVE on http://127.0.0.1:5000</a:t>
+              <a:t>Multi-file uploads (PDF, ZIP, code) with instant assignment publishing</a:t>
             </a:r>
           </a:p>
           <a:p>
@@ -4400,7 +4400,7 @@
               </a:defRPr>
             </a:pPr>
             <a:r>
-              <a:t>• Multi-Month Calendar:</a:t>
+              <a:t>• AI Automated Assessment:</a:t>
             </a:r>
           </a:p>
           <a:p>
@@ -4413,7 +4413,7 @@
               </a:defRPr>
             </a:pPr>
             <a:r>
-              <a:t>90 Days Active (Aug-Oct 2026)</a:t>
+              <a:t>Evaluates student code under teacher assignments &amp; marks Complete</a:t>
             </a:r>
           </a:p>
           <a:p>
@@ -4426,7 +4426,7 @@
               </a:defRPr>
             </a:pPr>
             <a:r>
-              <a:t>• AI Engine Response:</a:t>
+              <a:t>• Interactive AI Arena Suite:</a:t>
             </a:r>
           </a:p>
           <a:p>
@@ -4439,7 +4439,7 @@
               </a:defRPr>
             </a:pPr>
             <a:r>
-              <a:t>&lt; 250ms Local AST / Gemini 2.0</a:t>
+              <a:t>&lt; 250ms response: Roast, Big-O Optimizer &amp; FAANG Mock Interview</a:t>
             </a:r>
           </a:p>
           <a:p>
@@ -4452,7 +4452,7 @@
               </a:defRPr>
             </a:pPr>
             <a:r>
-              <a:t>• Preloaded Data State:</a:t>
+              <a:t>• 90-Day Activity Matrix:</a:t>
             </a:r>
           </a:p>
           <a:p>
@@ -4465,7 +4465,7 @@
               </a:defRPr>
             </a:pPr>
             <a:r>
-              <a:t>Clean baseline: 0 fake records</a:t>
+              <a:t>Aug-Oct 2026 synced LeetCode DSA + GitHub commit heatmaps</a:t>
             </a:r>
           </a:p>
           <a:p>
@@ -4478,7 +4478,7 @@
               </a:defRPr>
             </a:pPr>
             <a:r>
-              <a:t>• Verified Accounts:</a:t>
+              <a:t>• Verified User Accounts:</a:t>
             </a:r>
           </a:p>
           <a:p>
@@ -4491,11 +4491,11 @@
               </a:defRPr>
             </a:pPr>
             <a:r>
-              <a:t>Faculty (ID: faculty@12345)</a:t>
+              <a:t>Faculty (faculty@12345) &amp; Student (funwithcode8630@gmail.com)</a:t>
             </a:r>
             <a:br/>
             <a:r>
-              <a:t>Student (funwithcode8630@...)</a:t>
+              <a:t/>
             </a:r>
           </a:p>
           <a:p>
@@ -5270,7 +5270,7 @@
                         </a:defRPr>
                       </a:pPr>
                       <a:r>
-                        <a:t>AI Code Arena Big-O</a:t>
+                        <a:t>Faculty Coursework Upload</a:t>
                       </a:r>
                     </a:p>
                   </a:txBody>
@@ -5294,7 +5294,7 @@
                         </a:defRPr>
                       </a:pPr>
                       <a:r>
-                        <a:t>POST /api/ai/code-arena with recursive fib(n)</a:t>
+                        <a:t>Faculty uploads assignment with starter code ZIP &amp; lab PDF</a:t>
                       </a:r>
                     </a:p>
                   </a:txBody>
@@ -5318,7 +5318,7 @@
                         </a:defRPr>
                       </a:pPr>
                       <a:r>
-                        <a:t>Detects O(2^N) exponential time; rewrites to O(N). Actual: O(2^N)-&gt;O(N) generated.</a:t>
+                        <a:t>File safely persisted in uploads/ and attached to assignment. Actual: HTTP 201 Created, attached.</a:t>
                       </a:r>
                     </a:p>
                   </a:txBody>
@@ -5392,7 +5392,7 @@
                         </a:defRPr>
                       </a:pPr>
                       <a:r>
-                        <a:t>FAANG Mock Interview</a:t>
+                        <a:t>Assignment Submission &amp; AI Auto-Mark</a:t>
                       </a:r>
                     </a:p>
                   </a:txBody>
@@ -5416,7 +5416,7 @@
                         </a:defRPr>
                       </a:pPr>
                       <a:r>
-                        <a:t>POST /api/ai/mock-interview (Google DP round)</a:t>
+                        <a:t>Student submits code under teacher assignment to /api/assignments/&lt;id&gt;/submit</a:t>
                       </a:r>
                     </a:p>
                   </a:txBody>
@@ -5440,7 +5440,7 @@
                         </a:defRPr>
                       </a:pPr>
                       <a:r>
-                        <a:t>Evaluates complexity &amp; invariants; awards XP &amp; coins. Actual: LEANING HIRE (+80 XP).</a:t>
+                        <a:t>Gemini AI parses code, checks rubrics, awards score (94/100) and marks status Complete. Actual: Complete.</a:t>
                       </a:r>
                     </a:p>
                   </a:txBody>
@@ -5514,7 +5514,7 @@
                         </a:defRPr>
                       </a:pPr>
                       <a:r>
-                        <a:t>Faculty Access Separation</a:t>
+                        <a:t>AI Code Arena &amp; Interactive Play</a:t>
                       </a:r>
                     </a:p>
                   </a:txBody>
@@ -5538,7 +5538,7 @@
                         </a:defRPr>
                       </a:pPr>
                       <a:r>
-                        <a:t>Student user accessing /faculty portal endpoint</a:t>
+                        <a:t>Student inputs O(2^N) code snippet into AI Arena Roast / Optimize</a:t>
                       </a:r>
                     </a:p>
                   </a:txBody>
@@ -5562,7 +5562,7 @@
                         </a:defRPr>
                       </a:pPr>
                       <a:r>
-                        <a:t>Access restricted; redirect to student portal. Actual: HTTP 403 Forbidden enforced.</a:t>
+                        <a:t>Detects exponential time; delivers roast, O(N) refactor &amp; 5 edge cases. Actual: Analysis generated.</a:t>
                       </a:r>
                     </a:p>
                   </a:txBody>
@@ -5892,7 +5892,7 @@
               </a:defRPr>
             </a:pPr>
             <a:r>
-              <a:t>• Successful Technical Delivery:</a:t>
+              <a:t>• Complete Coursework Lifecycle Delivered:</a:t>
             </a:r>
           </a:p>
           <a:p>
@@ -5905,7 +5905,7 @@
               </a:defRPr>
             </a:pPr>
             <a:r>
-              <a:t>Constructed an end-to-end full-stack campus platform connecting university academics with live competitive programming telemetry.</a:t>
+              <a:t>Engineered seamless flow: faculty upload any coursework/starter files, students submit under specific teacher assignments, and Gemini AI assesses code to mark it Complete.</a:t>
             </a:r>
           </a:p>
           <a:p>
@@ -5918,7 +5918,7 @@
               </a:defRPr>
             </a:pPr>
             <a:r>
-              <a:t>• All Objectives Satisfied:</a:t>
+              <a:t>• Interactive AI Developer Playground:</a:t>
             </a:r>
           </a:p>
           <a:p>
@@ -5931,7 +5931,7 @@
               </a:defRPr>
             </a:pPr>
             <a:r>
-              <a:t>Delivered 90-day dual synchronization, multimodal AI diagnostic engine, gamified ByteCoin economy, and faculty evaluation workflow.</a:t>
+              <a:t>Integrated AI Code Arena (Roast, Turbo Optimize, Edge Cases) and FAANG Mock Interviewer for students to play, practice, and optimize code.</a:t>
             </a:r>
           </a:p>
           <a:p>
@@ -5944,7 +5944,7 @@
               </a:defRPr>
             </a:pPr>
             <a:r>
-              <a:t>• Security &amp; Documentation Hardening:</a:t>
+              <a:t>• 90-Day Dual Matrix &amp; Gamified Economy:</a:t>
             </a:r>
           </a:p>
           <a:p>
@@ -5957,7 +5957,7 @@
               </a:defRPr>
             </a:pPr>
             <a:r>
-              <a:t>Eliminated demo bypass vulnerabilities, reinforced strict session guards, and cleaned all dummy database entries for production baseline.</a:t>
+              <a:t>Synchronized LeetCode DSA solves with GitHub commits, backed by XP levels, ByteCoins shop, and streak rewards.</a:t>
             </a:r>
           </a:p>
           <a:p>
@@ -5970,7 +5970,7 @@
               </a:defRPr>
             </a:pPr>
             <a:r>
-              <a:t>• Key Team Learning:</a:t>
+              <a:t>• Production-Grade Security &amp; Hardening:</a:t>
             </a:r>
           </a:p>
           <a:p>
@@ -5983,7 +5983,7 @@
               </a:defRPr>
             </a:pPr>
             <a:r>
-              <a:t>Acquired practical expertise in full-stack REST API development, SQLite normalization, session-based access control, and resilient AI fallback architectures.</a:t>
+              <a:t>Strict session guards (@faculty_required, @student_required) prevent unauthorized bypasses with zero dummy database pollution.</a:t>
             </a:r>
           </a:p>
         </p:txBody>
@@ -7409,7 +7409,7 @@
               </a:defRPr>
             </a:pPr>
             <a:r>
-              <a:t>6 Core modules: Auth, Dual Matrix, AI Hub, Shop, Faculty &amp; Notices</a:t>
+              <a:t>Auth, 90-Day Matrix, AI Assessment &amp; Arena, ByteCoins, Faculty Hub &amp; Notices</a:t>
             </a:r>
           </a:p>
         </p:txBody>
@@ -8194,7 +8194,7 @@
               </a:defRPr>
             </a:pPr>
             <a:r>
-              <a:t>• Equips faculty with AI-assisted coursework drafting and automated rubric evaluation, modernizing college governance.</a:t>
+              <a:t>• Equips faculty with multi-format coursework uploads and automated AI assessment that marks student submissions complete with instant rubric feedback.</a:t>
             </a:r>
           </a:p>
         </p:txBody>
@@ -8493,7 +8493,7 @@
               </a:defRPr>
             </a:pPr>
             <a:r>
-              <a:t>• To build a dedicated Faculty Portal enabling targeted coursework publishing, AI rubric auto-grading, and campus bulletin broadcasting.</a:t>
+              <a:t>• To engineer a closed-loop coursework lifecycle: faculty upload assignments &amp; starter code, students submit directly under teacher assignments, and Gemini AI auto-assesses code to mark completion.</a:t>
             </a:r>
           </a:p>
           <a:p>
@@ -8506,7 +8506,7 @@
               </a:defRPr>
             </a:pPr>
             <a:r>
-              <a:t>• To implement strict session-based authentication preventing bypasses via cryptographic cookies and role guards (@faculty_required).</a:t>
+              <a:t>• To provide an interactive AI developer playground (AI Code Arena with Roast/Turbo/Edge Cases and FAANG Mock Interviewer) alongside strict session-guarded RBAC.</a:t>
             </a:r>
           </a:p>
         </p:txBody>
@@ -8613,7 +8613,7 @@
               </a:defRPr>
             </a:pPr>
             <a:r>
-              <a:t>  - Interactive AI Code Arena (Roast, Turbo Optimize, Edge Cases).</a:t>
+              <a:t>  - Teacher Coursework &amp; File Upload Engine (upload PDFs, starter code ZIPs, datasets).</a:t>
             </a:r>
           </a:p>
           <a:p>
@@ -8626,7 +8626,7 @@
               </a:defRPr>
             </a:pPr>
             <a:r>
-              <a:t>  - FAANG Mock Interview Challenge Simulator with XP rewards.</a:t>
+              <a:t>  - Student Submissions directly under Teacher Assignments with AI completion marking.</a:t>
             </a:r>
           </a:p>
           <a:p>
@@ -8639,7 +8639,7 @@
               </a:defRPr>
             </a:pPr>
             <a:r>
-              <a:t>  - Coursework submission queue with file uploads and faculty grading.</a:t>
+              <a:t>  - Gemini AI automated rubric grading engine (&lt; 1.5s evaluation with score &amp; feedback).</a:t>
             </a:r>
           </a:p>
           <a:p>
@@ -8652,7 +8652,7 @@
               </a:defRPr>
             </a:pPr>
             <a:r>
-              <a:t>  - Campus circular broadcasting with priority urgency alerts.</a:t>
+              <a:t>  - Interactive AI Code Arena (Roast, Big-O Turbo, Edge Cases) &amp; FAANG Mock Simulator.</a:t>
             </a:r>
           </a:p>
           <a:p>
@@ -9209,7 +9209,7 @@
                         </a:defRPr>
                       </a:pPr>
                       <a:r>
-                        <a:t>Gamified ByteCoin economy, progressive leveling (1-50), daily streaks &amp; shop customizers.</a:t>
+                        <a:t>Gamified ByteCoin economy, leveling (1-50), streaks &amp; interactive AI Code Arena to play and optimize.</a:t>
                       </a:r>
                     </a:p>
                   </a:txBody>
@@ -9235,7 +9235,7 @@
                         </a:defRPr>
                       </a:pPr>
                       <a:r>
-                        <a:t>Faculty Workload</a:t>
+                        <a:t>Coursework &amp; AI Grading</a:t>
                       </a:r>
                     </a:p>
                   </a:txBody>
@@ -9283,7 +9283,7 @@
                         </a:defRPr>
                       </a:pPr>
                       <a:r>
-                        <a:t>AI-assisted assignment drafting, automated rubric suggestions, 1-click evaluation.</a:t>
+                        <a:t>Faculty upload any coursework; students submit under assignment; Gemini AI auto-assesses &amp; marks complete.</a:t>
                       </a:r>
                     </a:p>
                   </a:txBody>
@@ -10244,7 +10244,7 @@
               </a:defRPr>
             </a:pPr>
             <a:r>
-              <a:t>  Multimodal intelligence API for real-time analysis</a:t>
+              <a:t>  Multimodal intelligence API for real-time analysis &amp; auto-grading</a:t>
             </a:r>
           </a:p>
           <a:p>
@@ -10296,7 +10296,7 @@
               </a:defRPr>
             </a:pPr>
             <a:r>
-              <a:t>  Pattern-aware AST analysis for code review &amp; Big-O</a:t>
+              <a:t>  Pattern-aware analysis for code review, Big-O &amp; rubric scoring</a:t>
             </a:r>
           </a:p>
           <a:p>
@@ -11816,7 +11816,7 @@
               </a:defRPr>
             </a:pPr>
             <a:r>
-              <a:t>• Dual-Engine AI Redundancy:</a:t>
+              <a:t>• Closed-Loop AI Assessment Pipeline:</a:t>
             </a:r>
           </a:p>
           <a:p>
@@ -11829,7 +11829,7 @@
               </a:defRPr>
             </a:pPr>
             <a:r>
-              <a:t>Integrates Google Gemini 2.0 Flash for cloud reasoning with an AST-driven local heuristic engine when offline or network-constrained.</a:t>
+              <a:t>Submissions under teacher assignments trigger Gemini AI evaluation pipeline, assessing code against rubrics and marking complete in SQLite.</a:t>
             </a:r>
           </a:p>
           <a:p>
@@ -12217,7 +12217,7 @@
               </a:defRPr>
             </a:pPr>
             <a:r>
-              <a:t>• Sprint 4: Multimodal AI &amp; Gamification:</a:t>
+              <a:t>• Sprint 4: Coursework AI &amp; Arena Hub:</a:t>
             </a:r>
           </a:p>
           <a:p>
@@ -12230,7 +12230,7 @@
               </a:defRPr>
             </a:pPr>
             <a:r>
-              <a:t>Integrated Google Gemini 2.0 Flash, AI Code Arena, FAANG Mock Interviewer, and the ByteCoins virtual shop.</a:t>
+              <a:t>Integrated faculty coursework uploads, student assignment submissions, Gemini AI auto-marking complete, and AI Code Arena.</a:t>
             </a:r>
           </a:p>
           <a:p>

</xml_diff>